<commit_message>
added web server and some bugfixes with specific Pedal models
</commit_message>
<xml_diff>
--- a/presentations/Expression Controller Final.pptx
+++ b/presentations/Expression Controller Final.pptx
@@ -11,10 +11,10 @@
   <p:sldIdLst>
     <p:sldId id="358" r:id="rId3"/>
     <p:sldId id="359" r:id="rId4"/>
-    <p:sldId id="360" r:id="rId5"/>
-    <p:sldId id="371" r:id="rId6"/>
+    <p:sldId id="371" r:id="rId5"/>
+    <p:sldId id="372" r:id="rId6"/>
     <p:sldId id="363" r:id="rId7"/>
-    <p:sldId id="369" r:id="rId8"/>
+    <p:sldId id="373" r:id="rId8"/>
     <p:sldId id="361" r:id="rId9"/>
     <p:sldId id="370" r:id="rId10"/>
     <p:sldId id="362" r:id="rId11"/>
@@ -309,7 +309,7 @@
           <a:p>
             <a:fld id="{00A6180F-3EA1-4748-B4F4-956BB5176995}" type="datetimeFigureOut">
               <a:rPr lang="de-DE" smtClean="0"/>
-              <a:t>08.07.26</a:t>
+              <a:t>28.09.2026</a:t>
             </a:fld>
             <a:endParaRPr lang="de-DE"/>
           </a:p>
@@ -1722,155 +1722,6 @@
         <p:cNvPr id="1" name="">
           <a:extLst>
             <a:ext uri="{FF2B5EF4-FFF2-40B4-BE49-F238E27FC236}">
-              <a16:creationId xmlns:a16="http://schemas.microsoft.com/office/drawing/2014/main" id="{F40996EC-2983-EC88-CA7B-2181109AC5BB}"/>
-            </a:ext>
-          </a:extLst>
-        </p:cNvPr>
-        <p:cNvGrpSpPr/>
-        <p:nvPr/>
-      </p:nvGrpSpPr>
-      <p:grpSpPr>
-        <a:xfrm>
-          <a:off x="0" y="0"/>
-          <a:ext cx="0" cy="0"/>
-          <a:chOff x="0" y="0"/>
-          <a:chExt cx="0" cy="0"/>
-        </a:xfrm>
-      </p:grpSpPr>
-      <p:sp>
-        <p:nvSpPr>
-          <p:cNvPr id="2" name="Slide Image Placeholder 1">
-            <a:extLst>
-              <a:ext uri="{FF2B5EF4-FFF2-40B4-BE49-F238E27FC236}">
-                <a16:creationId xmlns:a16="http://schemas.microsoft.com/office/drawing/2014/main" id="{988BD5F8-9A52-BF17-4FEF-158C2643BAD6}"/>
-              </a:ext>
-            </a:extLst>
-          </p:cNvPr>
-          <p:cNvSpPr>
-            <a:spLocks noGrp="1" noRot="1" noChangeAspect="1"/>
-          </p:cNvSpPr>
-          <p:nvPr>
-            <p:ph type="sldImg"/>
-          </p:nvPr>
-        </p:nvSpPr>
-        <p:spPr/>
-      </p:sp>
-      <p:sp>
-        <p:nvSpPr>
-          <p:cNvPr id="3" name="Notes Placeholder 2">
-            <a:extLst>
-              <a:ext uri="{FF2B5EF4-FFF2-40B4-BE49-F238E27FC236}">
-                <a16:creationId xmlns:a16="http://schemas.microsoft.com/office/drawing/2014/main" id="{BCCAFDD5-65ED-519D-A28D-7ACE483D70EE}"/>
-              </a:ext>
-            </a:extLst>
-          </p:cNvPr>
-          <p:cNvSpPr>
-            <a:spLocks noGrp="1"/>
-          </p:cNvSpPr>
-          <p:nvPr>
-            <p:ph type="body" idx="1"/>
-          </p:nvPr>
-        </p:nvSpPr>
-        <p:spPr/>
-        <p:txBody>
-          <a:bodyPr/>
-          <a:lstStyle/>
-          <a:p>
-            <a:pPr marL="171450" indent="-171450">
-              <a:buFont typeface="Arial" panose="020B0604020202020204" pitchFamily="34" charset="0"/>
-              <a:buChar char="•"/>
-            </a:pPr>
-            <a:r>
-              <a:rPr lang="en-US" dirty="0"/>
-              <a:t>Model: Two resistors A and B</a:t>
-            </a:r>
-          </a:p>
-          <a:p>
-            <a:pPr marL="171450" indent="-171450">
-              <a:buFont typeface="Arial" panose="020B0604020202020204" pitchFamily="34" charset="0"/>
-              <a:buChar char="•"/>
-            </a:pPr>
-            <a:r>
-              <a:rPr lang="en-US" dirty="0"/>
-              <a:t>How do we detect which tap is connected to which part of this network?</a:t>
-            </a:r>
-          </a:p>
-          <a:p>
-            <a:pPr marL="171450" indent="-171450">
-              <a:buFont typeface="Arial" panose="020B0604020202020204" pitchFamily="34" charset="0"/>
-              <a:buChar char="•"/>
-            </a:pPr>
-            <a:r>
-              <a:rPr lang="en-US" dirty="0">
-                <a:sym typeface="Wingdings" pitchFamily="2" charset="2"/>
-              </a:rPr>
-              <a:t>More general form: three-terminal resistive network</a:t>
-            </a:r>
-          </a:p>
-          <a:p>
-            <a:pPr marL="171450" indent="-171450">
-              <a:buFont typeface="Arial" panose="020B0604020202020204" pitchFamily="34" charset="0"/>
-              <a:buChar char="•"/>
-            </a:pPr>
-            <a:r>
-              <a:rPr lang="en-US" dirty="0">
-                <a:sym typeface="Wingdings" pitchFamily="2" charset="2"/>
-              </a:rPr>
-              <a:t> Introduction of a third resistor</a:t>
-            </a:r>
-          </a:p>
-        </p:txBody>
-      </p:sp>
-      <p:sp>
-        <p:nvSpPr>
-          <p:cNvPr id="4" name="Slide Number Placeholder 3">
-            <a:extLst>
-              <a:ext uri="{FF2B5EF4-FFF2-40B4-BE49-F238E27FC236}">
-                <a16:creationId xmlns:a16="http://schemas.microsoft.com/office/drawing/2014/main" id="{0BD08588-C0D5-4D9D-D559-88896AA8D26F}"/>
-              </a:ext>
-            </a:extLst>
-          </p:cNvPr>
-          <p:cNvSpPr>
-            <a:spLocks noGrp="1"/>
-          </p:cNvSpPr>
-          <p:nvPr>
-            <p:ph type="sldNum" sz="quarter" idx="5"/>
-          </p:nvPr>
-        </p:nvSpPr>
-        <p:spPr/>
-        <p:txBody>
-          <a:bodyPr/>
-          <a:lstStyle/>
-          <a:p>
-            <a:fld id="{F13C3961-1900-1342-BF9B-82C3215CD312}" type="slidenum">
-              <a:rPr lang="de-DE" smtClean="0"/>
-              <a:t>3</a:t>
-            </a:fld>
-            <a:endParaRPr lang="de-DE"/>
-          </a:p>
-        </p:txBody>
-      </p:sp>
-    </p:spTree>
-    <p:extLst>
-      <p:ext uri="{BB962C8B-B14F-4D97-AF65-F5344CB8AC3E}">
-        <p14:creationId xmlns:p14="http://schemas.microsoft.com/office/powerpoint/2010/main" val="2558698931"/>
-      </p:ext>
-    </p:extLst>
-  </p:cSld>
-  <p:clrMapOvr>
-    <a:masterClrMapping/>
-  </p:clrMapOvr>
-</p:notes>
-</file>
-
-<file path=ppt/notesSlides/notesSlide4.xml><?xml version="1.0" encoding="utf-8"?>
-<p:notes xmlns:a="http://schemas.openxmlformats.org/drawingml/2006/main" xmlns:r="http://schemas.openxmlformats.org/officeDocument/2006/relationships" xmlns:p="http://schemas.openxmlformats.org/presentationml/2006/main">
-  <p:cSld>
-    <p:spTree>
-      <p:nvGrpSpPr>
-        <p:cNvPr id="1" name="">
-          <a:extLst>
-            <a:ext uri="{FF2B5EF4-FFF2-40B4-BE49-F238E27FC236}">
               <a16:creationId xmlns:a16="http://schemas.microsoft.com/office/drawing/2014/main" id="{F2DB2924-AD1D-9CB8-B30E-C00936B5632B}"/>
             </a:ext>
           </a:extLst>
@@ -1973,7 +1824,7 @@
           <a:p>
             <a:fld id="{F13C3961-1900-1342-BF9B-82C3215CD312}" type="slidenum">
               <a:rPr lang="de-DE" smtClean="0"/>
-              <a:t>4</a:t>
+              <a:t>3</a:t>
             </a:fld>
             <a:endParaRPr lang="de-DE"/>
           </a:p>
@@ -1983,6 +1834,120 @@
     <p:extLst>
       <p:ext uri="{BB962C8B-B14F-4D97-AF65-F5344CB8AC3E}">
         <p14:creationId xmlns:p14="http://schemas.microsoft.com/office/powerpoint/2010/main" val="1710630245"/>
+      </p:ext>
+    </p:extLst>
+  </p:cSld>
+  <p:clrMapOvr>
+    <a:masterClrMapping/>
+  </p:clrMapOvr>
+</p:notes>
+</file>
+
+<file path=ppt/notesSlides/notesSlide4.xml><?xml version="1.0" encoding="utf-8"?>
+<p:notes xmlns:a="http://schemas.openxmlformats.org/drawingml/2006/main" xmlns:r="http://schemas.openxmlformats.org/officeDocument/2006/relationships" xmlns:p="http://schemas.openxmlformats.org/presentationml/2006/main">
+  <p:cSld>
+    <p:spTree>
+      <p:nvGrpSpPr>
+        <p:cNvPr id="1" name="">
+          <a:extLst>
+            <a:ext uri="{FF2B5EF4-FFF2-40B4-BE49-F238E27FC236}">
+              <a16:creationId xmlns:a16="http://schemas.microsoft.com/office/drawing/2014/main" id="{98ECDC3C-4E60-DB56-EE58-9AFF517A9C9C}"/>
+            </a:ext>
+          </a:extLst>
+        </p:cNvPr>
+        <p:cNvGrpSpPr/>
+        <p:nvPr/>
+      </p:nvGrpSpPr>
+      <p:grpSpPr>
+        <a:xfrm>
+          <a:off x="0" y="0"/>
+          <a:ext cx="0" cy="0"/>
+          <a:chOff x="0" y="0"/>
+          <a:chExt cx="0" cy="0"/>
+        </a:xfrm>
+      </p:grpSpPr>
+      <p:sp>
+        <p:nvSpPr>
+          <p:cNvPr id="2" name="Slide Image Placeholder 1">
+            <a:extLst>
+              <a:ext uri="{FF2B5EF4-FFF2-40B4-BE49-F238E27FC236}">
+                <a16:creationId xmlns:a16="http://schemas.microsoft.com/office/drawing/2014/main" id="{74A40202-C30C-5447-8D98-7542A96C5F5B}"/>
+              </a:ext>
+            </a:extLst>
+          </p:cNvPr>
+          <p:cNvSpPr>
+            <a:spLocks noGrp="1" noRot="1" noChangeAspect="1"/>
+          </p:cNvSpPr>
+          <p:nvPr>
+            <p:ph type="sldImg"/>
+          </p:nvPr>
+        </p:nvSpPr>
+        <p:spPr/>
+      </p:sp>
+      <p:sp>
+        <p:nvSpPr>
+          <p:cNvPr id="3" name="Notes Placeholder 2">
+            <a:extLst>
+              <a:ext uri="{FF2B5EF4-FFF2-40B4-BE49-F238E27FC236}">
+                <a16:creationId xmlns:a16="http://schemas.microsoft.com/office/drawing/2014/main" id="{9856B4C7-5774-EC07-0D8E-B957D058DC0D}"/>
+              </a:ext>
+            </a:extLst>
+          </p:cNvPr>
+          <p:cNvSpPr>
+            <a:spLocks noGrp="1"/>
+          </p:cNvSpPr>
+          <p:nvPr>
+            <p:ph type="body" idx="1"/>
+          </p:nvPr>
+        </p:nvSpPr>
+        <p:spPr/>
+        <p:txBody>
+          <a:bodyPr/>
+          <a:lstStyle/>
+          <a:p>
+            <a:pPr marL="171450" indent="-171450">
+              <a:buFont typeface="Arial" panose="020B0604020202020204" pitchFamily="34" charset="0"/>
+              <a:buChar char="•"/>
+            </a:pPr>
+            <a:endParaRPr lang="en-US" dirty="0">
+              <a:sym typeface="Wingdings" pitchFamily="2" charset="2"/>
+            </a:endParaRPr>
+          </a:p>
+        </p:txBody>
+      </p:sp>
+      <p:sp>
+        <p:nvSpPr>
+          <p:cNvPr id="4" name="Slide Number Placeholder 3">
+            <a:extLst>
+              <a:ext uri="{FF2B5EF4-FFF2-40B4-BE49-F238E27FC236}">
+                <a16:creationId xmlns:a16="http://schemas.microsoft.com/office/drawing/2014/main" id="{875825DD-9B9A-F943-F4C4-D2BE3269C4E0}"/>
+              </a:ext>
+            </a:extLst>
+          </p:cNvPr>
+          <p:cNvSpPr>
+            <a:spLocks noGrp="1"/>
+          </p:cNvSpPr>
+          <p:nvPr>
+            <p:ph type="sldNum" sz="quarter" idx="5"/>
+          </p:nvPr>
+        </p:nvSpPr>
+        <p:spPr/>
+        <p:txBody>
+          <a:bodyPr/>
+          <a:lstStyle/>
+          <a:p>
+            <a:fld id="{F13C3961-1900-1342-BF9B-82C3215CD312}" type="slidenum">
+              <a:rPr lang="de-DE" smtClean="0"/>
+              <a:t>4</a:t>
+            </a:fld>
+            <a:endParaRPr lang="de-DE"/>
+          </a:p>
+        </p:txBody>
+      </p:sp>
+    </p:spTree>
+    <p:extLst>
+      <p:ext uri="{BB962C8B-B14F-4D97-AF65-F5344CB8AC3E}">
+        <p14:creationId xmlns:p14="http://schemas.microsoft.com/office/powerpoint/2010/main" val="2430722294"/>
       </p:ext>
     </p:extLst>
   </p:cSld>
@@ -2141,7 +2106,7 @@
         <p:cNvPr id="1" name="">
           <a:extLst>
             <a:ext uri="{FF2B5EF4-FFF2-40B4-BE49-F238E27FC236}">
-              <a16:creationId xmlns:a16="http://schemas.microsoft.com/office/drawing/2014/main" id="{EC7A40FB-B468-54DA-A058-7778D49E8A94}"/>
+              <a16:creationId xmlns:a16="http://schemas.microsoft.com/office/drawing/2014/main" id="{9ABAD05A-C679-1212-A6D3-7035813D4749}"/>
             </a:ext>
           </a:extLst>
         </p:cNvPr>
@@ -2161,7 +2126,7 @@
           <p:cNvPr id="2" name="Slide Image Placeholder 1">
             <a:extLst>
               <a:ext uri="{FF2B5EF4-FFF2-40B4-BE49-F238E27FC236}">
-                <a16:creationId xmlns:a16="http://schemas.microsoft.com/office/drawing/2014/main" id="{2D129511-745A-231C-AC70-4C7114C4324F}"/>
+                <a16:creationId xmlns:a16="http://schemas.microsoft.com/office/drawing/2014/main" id="{ECD22D33-25F7-374B-27B5-95DEB138A8CB}"/>
               </a:ext>
             </a:extLst>
           </p:cNvPr>
@@ -2179,7 +2144,7 @@
           <p:cNvPr id="3" name="Notes Placeholder 2">
             <a:extLst>
               <a:ext uri="{FF2B5EF4-FFF2-40B4-BE49-F238E27FC236}">
-                <a16:creationId xmlns:a16="http://schemas.microsoft.com/office/drawing/2014/main" id="{D084DFB6-EEE6-FB1D-09EB-C9E287B2EED6}"/>
+                <a16:creationId xmlns:a16="http://schemas.microsoft.com/office/drawing/2014/main" id="{E60140CF-ADBD-0538-F3A0-B5FF224718D9}"/>
               </a:ext>
             </a:extLst>
           </p:cNvPr>
@@ -2199,96 +2164,9 @@
               <a:buFont typeface="Arial" panose="020B0604020202020204" pitchFamily="34" charset="0"/>
               <a:buChar char="•"/>
             </a:pPr>
-            <a:r>
-              <a:rPr lang="en-US" dirty="0">
-                <a:sym typeface="Wingdings" pitchFamily="2" charset="2"/>
-              </a:rPr>
-              <a:t>Hardware</a:t>
-            </a:r>
-          </a:p>
-          <a:p>
-            <a:pPr marL="628650" lvl="1" indent="-171450">
-              <a:buFont typeface="Arial" panose="020B0604020202020204" pitchFamily="34" charset="0"/>
-              <a:buChar char="•"/>
-            </a:pPr>
-            <a:r>
-              <a:rPr lang="en-US" dirty="0">
-                <a:sym typeface="Wingdings" pitchFamily="2" charset="2"/>
-              </a:rPr>
-              <a:t>Parts ordered for the prototype</a:t>
-            </a:r>
-          </a:p>
-          <a:p>
-            <a:pPr marL="628650" lvl="1" indent="-171450">
-              <a:buFont typeface="Arial" panose="020B0604020202020204" pitchFamily="34" charset="0"/>
-              <a:buChar char="•"/>
-            </a:pPr>
-            <a:r>
-              <a:rPr lang="en-US" dirty="0">
-                <a:sym typeface="Wingdings" pitchFamily="2" charset="2"/>
-              </a:rPr>
-              <a:t>Started working on it (but not presentable yet)</a:t>
-            </a:r>
-          </a:p>
-          <a:p>
-            <a:pPr marL="628650" lvl="1" indent="-171450">
-              <a:buFont typeface="Arial" panose="020B0604020202020204" pitchFamily="34" charset="0"/>
-              <a:buChar char="•"/>
-            </a:pPr>
-            <a:r>
-              <a:rPr lang="en-US" dirty="0">
-                <a:sym typeface="Wingdings" pitchFamily="2" charset="2"/>
-              </a:rPr>
-              <a:t>Routing</a:t>
-            </a:r>
-          </a:p>
-          <a:p>
-            <a:pPr marL="171450" lvl="0" indent="-171450">
-              <a:buFont typeface="Arial" panose="020B0604020202020204" pitchFamily="34" charset="0"/>
-              <a:buChar char="•"/>
-            </a:pPr>
-            <a:r>
-              <a:rPr lang="en-US" dirty="0">
-                <a:sym typeface="Wingdings" pitchFamily="2" charset="2"/>
-              </a:rPr>
-              <a:t>Firmware</a:t>
-            </a:r>
-          </a:p>
-          <a:p>
-            <a:pPr marL="628650" lvl="1" indent="-171450">
-              <a:buFont typeface="Arial" panose="020B0604020202020204" pitchFamily="34" charset="0"/>
-              <a:buChar char="•"/>
-            </a:pPr>
-            <a:r>
-              <a:rPr lang="en-US" dirty="0">
-                <a:sym typeface="Wingdings" pitchFamily="2" charset="2"/>
-              </a:rPr>
-              <a:t>Simulator will not be refined further</a:t>
-            </a:r>
-          </a:p>
-          <a:p>
-            <a:pPr marL="628650" lvl="1" indent="-171450">
-              <a:buFont typeface="Arial" panose="020B0604020202020204" pitchFamily="34" charset="0"/>
-              <a:buChar char="•"/>
-            </a:pPr>
-            <a:r>
-              <a:rPr lang="en-US" dirty="0">
-                <a:sym typeface="Wingdings" pitchFamily="2" charset="2"/>
-              </a:rPr>
-              <a:t>Start implementation on the Raspberry Pi Pico</a:t>
-            </a:r>
-          </a:p>
-          <a:p>
-            <a:pPr marL="171450" lvl="0" indent="-171450">
-              <a:buFont typeface="Arial" panose="020B0604020202020204" pitchFamily="34" charset="0"/>
-              <a:buChar char="•"/>
-            </a:pPr>
-            <a:r>
-              <a:rPr lang="en-US" dirty="0">
-                <a:sym typeface="Wingdings" pitchFamily="2" charset="2"/>
-              </a:rPr>
-              <a:t>NEXT PAGE: END!!!</a:t>
-            </a:r>
+            <a:endParaRPr lang="en-US" dirty="0">
+              <a:sym typeface="Wingdings" pitchFamily="2" charset="2"/>
+            </a:endParaRPr>
           </a:p>
         </p:txBody>
       </p:sp>
@@ -2297,7 +2175,7 @@
           <p:cNvPr id="4" name="Slide Number Placeholder 3">
             <a:extLst>
               <a:ext uri="{FF2B5EF4-FFF2-40B4-BE49-F238E27FC236}">
-                <a16:creationId xmlns:a16="http://schemas.microsoft.com/office/drawing/2014/main" id="{ED149E00-2AAA-8AC3-0F67-D2E8E6913D19}"/>
+                <a16:creationId xmlns:a16="http://schemas.microsoft.com/office/drawing/2014/main" id="{DB5DC46F-0E45-5580-B204-12EDE6C8224E}"/>
               </a:ext>
             </a:extLst>
           </p:cNvPr>
@@ -2324,7 +2202,7 @@
     </p:spTree>
     <p:extLst>
       <p:ext uri="{BB962C8B-B14F-4D97-AF65-F5344CB8AC3E}">
-        <p14:creationId xmlns:p14="http://schemas.microsoft.com/office/powerpoint/2010/main" val="659519762"/>
+        <p14:creationId xmlns:p14="http://schemas.microsoft.com/office/powerpoint/2010/main" val="3153521478"/>
       </p:ext>
     </p:extLst>
   </p:cSld>
@@ -5646,10 +5524,10 @@
           <p:nvPr userDrawn="1"/>
         </p:nvPicPr>
         <p:blipFill>
-          <a:blip r:embed="rId5">
+          <a:blip>
             <a:extLst>
               <a:ext uri="{96DAC541-7B7A-43D3-8B79-37D633B846F1}">
-                <asvg:svgBlip xmlns:asvg="http://schemas.microsoft.com/office/drawing/2016/SVG/main" r:embed="rId6"/>
+                <asvg:svgBlip xmlns:asvg="http://schemas.microsoft.com/office/drawing/2016/SVG/main" r:embed="rId5"/>
               </a:ext>
             </a:extLst>
           </a:blip>
@@ -5990,47 +5868,7 @@
                 <a:latin typeface="Arial" panose="020B0604020202020204" pitchFamily="34" charset="0"/>
                 <a:cs typeface="Arial" panose="020B0604020202020204" pitchFamily="34" charset="0"/>
               </a:rPr>
-              <a:t>Amon Benson | Sensor and </a:t>
-            </a:r>
-            <a:r>
-              <a:rPr lang="de-DE" sz="1200" dirty="0" err="1">
-                <a:solidFill>
-                  <a:schemeClr val="bg1"/>
-                </a:solidFill>
-                <a:latin typeface="Arial" panose="020B0604020202020204" pitchFamily="34" charset="0"/>
-                <a:cs typeface="Arial" panose="020B0604020202020204" pitchFamily="34" charset="0"/>
-              </a:rPr>
-              <a:t>Actuator</a:t>
-            </a:r>
-            <a:r>
-              <a:rPr lang="de-DE" sz="1200" dirty="0">
-                <a:solidFill>
-                  <a:schemeClr val="bg1"/>
-                </a:solidFill>
-                <a:latin typeface="Arial" panose="020B0604020202020204" pitchFamily="34" charset="0"/>
-                <a:cs typeface="Arial" panose="020B0604020202020204" pitchFamily="34" charset="0"/>
-              </a:rPr>
-              <a:t> Systems | Adapter </a:t>
-            </a:r>
-            <a:r>
-              <a:rPr lang="de-DE" sz="1200" dirty="0" err="1">
-                <a:solidFill>
-                  <a:schemeClr val="bg1"/>
-                </a:solidFill>
-                <a:latin typeface="Arial" panose="020B0604020202020204" pitchFamily="34" charset="0"/>
-                <a:cs typeface="Arial" panose="020B0604020202020204" pitchFamily="34" charset="0"/>
-              </a:rPr>
-              <a:t>for</a:t>
-            </a:r>
-            <a:r>
-              <a:rPr lang="de-DE" sz="1200" dirty="0">
-                <a:solidFill>
-                  <a:schemeClr val="bg1"/>
-                </a:solidFill>
-                <a:latin typeface="Arial" panose="020B0604020202020204" pitchFamily="34" charset="0"/>
-                <a:cs typeface="Arial" panose="020B0604020202020204" pitchFamily="34" charset="0"/>
-              </a:rPr>
-              <a:t> Expression Pedals | Milestone Meeting 2 | </a:t>
+              <a:t>Amon Benson | Sensor and Actuator Systems | Adapter for Expression Pedals | Final Presentation | </a:t>
             </a:r>
             <a:fld id="{8AB8AE3C-4F02-BE49-87A2-4A6516160ED6}" type="datetime4">
               <a:rPr lang="de-DE" sz="1200" smtClean="0">
@@ -6057,7 +5895,7 @@
                 <a:tabLst/>
                 <a:defRPr/>
               </a:pPr>
-              <a:t>8. Juli 2026</a:t>
+              <a:t>28. September 2026</a:t>
             </a:fld>
             <a:endParaRPr lang="de-DE" sz="1200" dirty="0">
               <a:solidFill>
@@ -6529,27 +6367,7 @@
                 <a:latin typeface="Arial" panose="020B0604020202020204" pitchFamily="34" charset="0"/>
                 <a:cs typeface="Arial" panose="020B0604020202020204" pitchFamily="34" charset="0"/>
               </a:rPr>
-              <a:t>Amon Benson | Sensor and </a:t>
-            </a:r>
-            <a:r>
-              <a:rPr lang="de-DE" sz="1800" dirty="0" err="1">
-                <a:solidFill>
-                  <a:schemeClr val="bg1"/>
-                </a:solidFill>
-                <a:latin typeface="Arial" panose="020B0604020202020204" pitchFamily="34" charset="0"/>
-                <a:cs typeface="Arial" panose="020B0604020202020204" pitchFamily="34" charset="0"/>
-              </a:rPr>
-              <a:t>Actuator</a:t>
-            </a:r>
-            <a:r>
-              <a:rPr lang="de-DE" sz="1800" dirty="0">
-                <a:solidFill>
-                  <a:schemeClr val="bg1"/>
-                </a:solidFill>
-                <a:latin typeface="Arial" panose="020B0604020202020204" pitchFamily="34" charset="0"/>
-                <a:cs typeface="Arial" panose="020B0604020202020204" pitchFamily="34" charset="0"/>
-              </a:rPr>
-              <a:t> Systems | </a:t>
+              <a:t>Amon Benson | Sensor and Actuator Systems | </a:t>
             </a:r>
             <a:r>
               <a:rPr lang="de-DE" dirty="0">
@@ -6559,7 +6377,7 @@
                 <a:latin typeface="Arial" panose="020B0604020202020204" pitchFamily="34" charset="0"/>
                 <a:cs typeface="Arial" panose="020B0604020202020204" pitchFamily="34" charset="0"/>
               </a:rPr>
-              <a:t>Milestone Meeting 2 </a:t>
+              <a:t>Final Presentation </a:t>
             </a:r>
             <a:r>
               <a:rPr lang="de-DE" sz="1800" dirty="0">
@@ -6596,7 +6414,7 @@
                 <a:tabLst/>
                 <a:defRPr/>
               </a:pPr>
-              <a:t>8. Juli 2026</a:t>
+              <a:t>28. September 2026</a:t>
             </a:fld>
             <a:endParaRPr lang="de-DE" sz="1800" dirty="0">
               <a:solidFill>
@@ -8240,100 +8058,6 @@
         <p:cNvPr id="1" name="">
           <a:extLst>
             <a:ext uri="{FF2B5EF4-FFF2-40B4-BE49-F238E27FC236}">
-              <a16:creationId xmlns:a16="http://schemas.microsoft.com/office/drawing/2014/main" id="{D3EA9B18-6DD8-4F81-7D9C-4E5CD3D896C3}"/>
-            </a:ext>
-          </a:extLst>
-        </p:cNvPr>
-        <p:cNvGrpSpPr/>
-        <p:nvPr/>
-      </p:nvGrpSpPr>
-      <p:grpSpPr>
-        <a:xfrm>
-          <a:off x="0" y="0"/>
-          <a:ext cx="0" cy="0"/>
-          <a:chOff x="0" y="0"/>
-          <a:chExt cx="0" cy="0"/>
-        </a:xfrm>
-      </p:grpSpPr>
-      <p:sp>
-        <p:nvSpPr>
-          <p:cNvPr id="5" name="Text Placeholder 4">
-            <a:extLst>
-              <a:ext uri="{FF2B5EF4-FFF2-40B4-BE49-F238E27FC236}">
-                <a16:creationId xmlns:a16="http://schemas.microsoft.com/office/drawing/2014/main" id="{BBD94683-346A-37B7-3BE8-B88B59216A0C}"/>
-              </a:ext>
-            </a:extLst>
-          </p:cNvPr>
-          <p:cNvSpPr>
-            <a:spLocks noGrp="1"/>
-          </p:cNvSpPr>
-          <p:nvPr>
-            <p:ph type="body" sz="quarter" idx="14"/>
-          </p:nvPr>
-        </p:nvSpPr>
-        <p:spPr/>
-        <p:txBody>
-          <a:bodyPr/>
-          <a:lstStyle/>
-          <a:p>
-            <a:r>
-              <a:rPr lang="en-US" dirty="0"/>
-              <a:t>Detection Process</a:t>
-            </a:r>
-          </a:p>
-        </p:txBody>
-      </p:sp>
-      <p:pic>
-        <p:nvPicPr>
-          <p:cNvPr id="3" name="Picture 2" descr="A diagram of a circuit&#10;&#10;AI-generated content may be incorrect.">
-            <a:extLst>
-              <a:ext uri="{FF2B5EF4-FFF2-40B4-BE49-F238E27FC236}">
-                <a16:creationId xmlns:a16="http://schemas.microsoft.com/office/drawing/2014/main" id="{981A51E5-1E4F-550F-39A0-A45575F28ADA}"/>
-              </a:ext>
-            </a:extLst>
-          </p:cNvPr>
-          <p:cNvPicPr>
-            <a:picLocks noChangeAspect="1"/>
-          </p:cNvPicPr>
-          <p:nvPr/>
-        </p:nvPicPr>
-        <p:blipFill>
-          <a:blip r:embed="rId3"/>
-          <a:stretch>
-            <a:fillRect/>
-          </a:stretch>
-        </p:blipFill>
-        <p:spPr>
-          <a:xfrm>
-            <a:off x="4199138" y="1477156"/>
-            <a:ext cx="3793724" cy="3903687"/>
-          </a:xfrm>
-          <a:prstGeom prst="rect">
-            <a:avLst/>
-          </a:prstGeom>
-        </p:spPr>
-      </p:pic>
-    </p:spTree>
-    <p:extLst>
-      <p:ext uri="{BB962C8B-B14F-4D97-AF65-F5344CB8AC3E}">
-        <p14:creationId xmlns:p14="http://schemas.microsoft.com/office/powerpoint/2010/main" val="2423323489"/>
-      </p:ext>
-    </p:extLst>
-  </p:cSld>
-  <p:clrMapOvr>
-    <a:masterClrMapping/>
-  </p:clrMapOvr>
-</p:sld>
-</file>
-
-<file path=ppt/slides/slide4.xml><?xml version="1.0" encoding="utf-8"?>
-<p:sld xmlns:a="http://schemas.openxmlformats.org/drawingml/2006/main" xmlns:r="http://schemas.openxmlformats.org/officeDocument/2006/relationships" xmlns:p="http://schemas.openxmlformats.org/presentationml/2006/main">
-  <p:cSld>
-    <p:spTree>
-      <p:nvGrpSpPr>
-        <p:cNvPr id="1" name="">
-          <a:extLst>
-            <a:ext uri="{FF2B5EF4-FFF2-40B4-BE49-F238E27FC236}">
               <a16:creationId xmlns:a16="http://schemas.microsoft.com/office/drawing/2014/main" id="{3CE6FF46-1122-DD88-35A5-A240614662E6}"/>
             </a:ext>
           </a:extLst>
@@ -8411,6 +8135,130 @@
     <p:extLst>
       <p:ext uri="{BB962C8B-B14F-4D97-AF65-F5344CB8AC3E}">
         <p14:creationId xmlns:p14="http://schemas.microsoft.com/office/powerpoint/2010/main" val="4085356742"/>
+      </p:ext>
+    </p:extLst>
+  </p:cSld>
+  <p:clrMapOvr>
+    <a:masterClrMapping/>
+  </p:clrMapOvr>
+</p:sld>
+</file>
+
+<file path=ppt/slides/slide4.xml><?xml version="1.0" encoding="utf-8"?>
+<p:sld xmlns:a="http://schemas.openxmlformats.org/drawingml/2006/main" xmlns:r="http://schemas.openxmlformats.org/officeDocument/2006/relationships" xmlns:p="http://schemas.openxmlformats.org/presentationml/2006/main">
+  <p:cSld>
+    <p:spTree>
+      <p:nvGrpSpPr>
+        <p:cNvPr id="1" name="">
+          <a:extLst>
+            <a:ext uri="{FF2B5EF4-FFF2-40B4-BE49-F238E27FC236}">
+              <a16:creationId xmlns:a16="http://schemas.microsoft.com/office/drawing/2014/main" id="{7770901E-85A5-30A1-8B73-CB40CB19706A}"/>
+            </a:ext>
+          </a:extLst>
+        </p:cNvPr>
+        <p:cNvGrpSpPr/>
+        <p:nvPr/>
+      </p:nvGrpSpPr>
+      <p:grpSpPr>
+        <a:xfrm>
+          <a:off x="0" y="0"/>
+          <a:ext cx="0" cy="0"/>
+          <a:chOff x="0" y="0"/>
+          <a:chExt cx="0" cy="0"/>
+        </a:xfrm>
+      </p:grpSpPr>
+      <p:sp>
+        <p:nvSpPr>
+          <p:cNvPr id="5" name="Text Placeholder 4">
+            <a:extLst>
+              <a:ext uri="{FF2B5EF4-FFF2-40B4-BE49-F238E27FC236}">
+                <a16:creationId xmlns:a16="http://schemas.microsoft.com/office/drawing/2014/main" id="{D8934EBB-BA2F-FF2A-5F2A-7BD3F8217871}"/>
+              </a:ext>
+            </a:extLst>
+          </p:cNvPr>
+          <p:cNvSpPr>
+            <a:spLocks noGrp="1"/>
+          </p:cNvSpPr>
+          <p:nvPr>
+            <p:ph type="body" sz="quarter" idx="14"/>
+          </p:nvPr>
+        </p:nvSpPr>
+        <p:spPr/>
+        <p:txBody>
+          <a:bodyPr/>
+          <a:lstStyle/>
+          <a:p>
+            <a:r>
+              <a:rPr lang="en-US" dirty="0"/>
+              <a:t>Detection Process</a:t>
+            </a:r>
+          </a:p>
+        </p:txBody>
+      </p:sp>
+      <p:pic>
+        <p:nvPicPr>
+          <p:cNvPr id="7" name="Picture 6">
+            <a:extLst>
+              <a:ext uri="{FF2B5EF4-FFF2-40B4-BE49-F238E27FC236}">
+                <a16:creationId xmlns:a16="http://schemas.microsoft.com/office/drawing/2014/main" id="{40617F49-0192-3873-D754-78B1C72BCB20}"/>
+              </a:ext>
+            </a:extLst>
+          </p:cNvPr>
+          <p:cNvPicPr>
+            <a:picLocks noChangeAspect="1"/>
+          </p:cNvPicPr>
+          <p:nvPr/>
+        </p:nvPicPr>
+        <p:blipFill>
+          <a:blip r:embed="rId3"/>
+          <a:stretch>
+            <a:fillRect/>
+          </a:stretch>
+        </p:blipFill>
+        <p:spPr>
+          <a:xfrm>
+            <a:off x="1070559" y="1720341"/>
+            <a:ext cx="4758741" cy="3417317"/>
+          </a:xfrm>
+          <a:prstGeom prst="rect">
+            <a:avLst/>
+          </a:prstGeom>
+        </p:spPr>
+      </p:pic>
+      <p:pic>
+        <p:nvPicPr>
+          <p:cNvPr id="9" name="Picture 8">
+            <a:extLst>
+              <a:ext uri="{FF2B5EF4-FFF2-40B4-BE49-F238E27FC236}">
+                <a16:creationId xmlns:a16="http://schemas.microsoft.com/office/drawing/2014/main" id="{ACE93369-F8FB-3BB3-31C2-6C92BF643213}"/>
+              </a:ext>
+            </a:extLst>
+          </p:cNvPr>
+          <p:cNvPicPr>
+            <a:picLocks noChangeAspect="1"/>
+          </p:cNvPicPr>
+          <p:nvPr/>
+        </p:nvPicPr>
+        <p:blipFill>
+          <a:blip r:embed="rId4"/>
+          <a:stretch>
+            <a:fillRect/>
+          </a:stretch>
+        </p:blipFill>
+        <p:spPr>
+          <a:xfrm>
+            <a:off x="6752671" y="1720341"/>
+            <a:ext cx="4595685" cy="3411875"/>
+          </a:xfrm>
+          <a:prstGeom prst="rect">
+            <a:avLst/>
+          </a:prstGeom>
+        </p:spPr>
+      </p:pic>
+    </p:spTree>
+    <p:extLst>
+      <p:ext uri="{BB962C8B-B14F-4D97-AF65-F5344CB8AC3E}">
+        <p14:creationId xmlns:p14="http://schemas.microsoft.com/office/powerpoint/2010/main" val="3963615737"/>
       </p:ext>
     </p:extLst>
   </p:cSld>
@@ -8471,357 +8319,306 @@
           </a:p>
         </p:txBody>
       </p:sp>
-      <p:pic>
-        <p:nvPicPr>
-          <p:cNvPr id="18" name="Picture 17" descr="A diagram of electrical wiring&#10;&#10;AI-generated content may be incorrect.">
-            <a:extLst>
-              <a:ext uri="{FF2B5EF4-FFF2-40B4-BE49-F238E27FC236}">
-                <a16:creationId xmlns:a16="http://schemas.microsoft.com/office/drawing/2014/main" id="{8C5B2813-7E4B-911E-E8F0-0DF6EFF832F2}"/>
-              </a:ext>
-            </a:extLst>
-          </p:cNvPr>
-          <p:cNvPicPr>
-            <a:picLocks noChangeAspect="1"/>
-          </p:cNvPicPr>
+      <p:grpSp>
+        <p:nvGrpSpPr>
+          <p:cNvPr id="11" name="Group 10">
+            <a:extLst>
+              <a:ext uri="{FF2B5EF4-FFF2-40B4-BE49-F238E27FC236}">
+                <a16:creationId xmlns:a16="http://schemas.microsoft.com/office/drawing/2014/main" id="{EB4EF6A6-97D9-AE4E-690B-060D8C0CBD00}"/>
+              </a:ext>
+            </a:extLst>
+          </p:cNvPr>
+          <p:cNvGrpSpPr/>
           <p:nvPr/>
-        </p:nvPicPr>
-        <p:blipFill>
-          <a:blip r:embed="rId3"/>
-          <a:srcRect l="26416"/>
-          <a:stretch>
-            <a:fillRect/>
-          </a:stretch>
-        </p:blipFill>
-        <p:spPr>
+        </p:nvGrpSpPr>
+        <p:grpSpPr>
           <a:xfrm>
-            <a:off x="6260123" y="638989"/>
-            <a:ext cx="4096651" cy="5150236"/>
+            <a:off x="3226359" y="638989"/>
+            <a:ext cx="5034915" cy="5150236"/>
+            <a:chOff x="5321859" y="638989"/>
+            <a:chExt cx="5034915" cy="5150236"/>
           </a:xfrm>
-          <a:prstGeom prst="rect">
-            <a:avLst/>
-          </a:prstGeom>
-        </p:spPr>
-      </p:pic>
-      <p:sp>
-        <p:nvSpPr>
-          <p:cNvPr id="2" name="TextBox 1">
-            <a:extLst>
-              <a:ext uri="{FF2B5EF4-FFF2-40B4-BE49-F238E27FC236}">
-                <a16:creationId xmlns:a16="http://schemas.microsoft.com/office/drawing/2014/main" id="{D1138688-ACD6-A9EC-4AA2-BA77A21142A2}"/>
-              </a:ext>
-            </a:extLst>
-          </p:cNvPr>
-          <p:cNvSpPr txBox="1"/>
-          <p:nvPr/>
-        </p:nvSpPr>
-        <p:spPr>
-          <a:xfrm>
-            <a:off x="9115864" y="638989"/>
-            <a:ext cx="1125415" cy="523220"/>
-          </a:xfrm>
-          <a:prstGeom prst="rect">
-            <a:avLst/>
-          </a:prstGeom>
-          <a:solidFill>
-            <a:schemeClr val="bg1"/>
-          </a:solidFill>
-        </p:spPr>
-        <p:txBody>
-          <a:bodyPr wrap="square" rtlCol="0">
-            <a:spAutoFit/>
-          </a:bodyPr>
-          <a:lstStyle/>
-          <a:p>
-            <a:r>
-              <a:rPr lang="en-US" sz="2800" dirty="0">
-                <a:solidFill>
-                  <a:schemeClr val="bg2">
-                    <a:lumMod val="10000"/>
-                  </a:schemeClr>
-                </a:solidFill>
-              </a:rPr>
-              <a:t>+</a:t>
-            </a:r>
-            <a:r>
-              <a:rPr lang="de-DE" sz="2800" dirty="0">
-                <a:solidFill>
-                  <a:schemeClr val="bg2">
-                    <a:lumMod val="10000"/>
-                  </a:schemeClr>
-                </a:solidFill>
-              </a:rPr>
-              <a:t>3.3</a:t>
-            </a:r>
-            <a:r>
-              <a:rPr lang="en-US" sz="2800" dirty="0">
-                <a:solidFill>
-                  <a:schemeClr val="bg2">
-                    <a:lumMod val="10000"/>
-                  </a:schemeClr>
-                </a:solidFill>
-              </a:rPr>
-              <a:t>V</a:t>
-            </a:r>
-          </a:p>
-        </p:txBody>
-      </p:sp>
-      <p:sp>
-        <p:nvSpPr>
-          <p:cNvPr id="3" name="TextBox 2">
-            <a:extLst>
-              <a:ext uri="{FF2B5EF4-FFF2-40B4-BE49-F238E27FC236}">
-                <a16:creationId xmlns:a16="http://schemas.microsoft.com/office/drawing/2014/main" id="{4C3D5FC2-4116-1C94-C0CD-F53CBF1B45CA}"/>
-              </a:ext>
-            </a:extLst>
-          </p:cNvPr>
-          <p:cNvSpPr txBox="1"/>
-          <p:nvPr/>
-        </p:nvSpPr>
-        <p:spPr>
-          <a:xfrm>
-            <a:off x="9115864" y="5266005"/>
-            <a:ext cx="1125415" cy="523220"/>
-          </a:xfrm>
-          <a:prstGeom prst="rect">
-            <a:avLst/>
-          </a:prstGeom>
-          <a:solidFill>
-            <a:schemeClr val="bg1"/>
-          </a:solidFill>
-        </p:spPr>
-        <p:txBody>
-          <a:bodyPr wrap="square" rtlCol="0">
-            <a:spAutoFit/>
-          </a:bodyPr>
-          <a:lstStyle/>
-          <a:p>
-            <a:r>
-              <a:rPr lang="en-US" sz="2800" dirty="0">
-                <a:solidFill>
-                  <a:schemeClr val="bg2">
-                    <a:lumMod val="10000"/>
-                  </a:schemeClr>
-                </a:solidFill>
-              </a:rPr>
-              <a:t>GND</a:t>
-            </a:r>
-          </a:p>
-        </p:txBody>
-      </p:sp>
-      <p:pic>
-        <p:nvPicPr>
-          <p:cNvPr id="4" name="Picture 3" descr="A diagram of electrical wiring&#10;&#10;AI-generated content may be incorrect.">
-            <a:extLst>
-              <a:ext uri="{FF2B5EF4-FFF2-40B4-BE49-F238E27FC236}">
-                <a16:creationId xmlns:a16="http://schemas.microsoft.com/office/drawing/2014/main" id="{E98700CC-887E-0697-C52C-2874EE6F1C50}"/>
-              </a:ext>
-            </a:extLst>
-          </p:cNvPr>
-          <p:cNvPicPr>
-            <a:picLocks noChangeAspect="1"/>
-          </p:cNvPicPr>
-          <p:nvPr/>
-        </p:nvPicPr>
-        <p:blipFill>
-          <a:blip r:embed="rId3"/>
-          <a:srcRect r="87259"/>
-          <a:stretch>
-            <a:fillRect/>
-          </a:stretch>
-        </p:blipFill>
-        <p:spPr>
-          <a:xfrm>
-            <a:off x="5689747" y="638989"/>
-            <a:ext cx="709348" cy="5150236"/>
-          </a:xfrm>
-          <a:prstGeom prst="rect">
-            <a:avLst/>
-          </a:prstGeom>
-        </p:spPr>
-      </p:pic>
-      <p:sp>
-        <p:nvSpPr>
-          <p:cNvPr id="8" name="TextBox 7">
-            <a:extLst>
-              <a:ext uri="{FF2B5EF4-FFF2-40B4-BE49-F238E27FC236}">
-                <a16:creationId xmlns:a16="http://schemas.microsoft.com/office/drawing/2014/main" id="{C4F020C3-EBC6-2172-DB34-B04E9D82184A}"/>
-              </a:ext>
-            </a:extLst>
-          </p:cNvPr>
-          <p:cNvSpPr txBox="1"/>
-          <p:nvPr/>
-        </p:nvSpPr>
-        <p:spPr>
-          <a:xfrm>
-            <a:off x="5321859" y="2293034"/>
-            <a:ext cx="681212" cy="369332"/>
-          </a:xfrm>
-          <a:prstGeom prst="rect">
-            <a:avLst/>
-          </a:prstGeom>
-          <a:solidFill>
-            <a:schemeClr val="bg1"/>
-          </a:solidFill>
-        </p:spPr>
-        <p:txBody>
-          <a:bodyPr wrap="none" rtlCol="0">
-            <a:spAutoFit/>
-          </a:bodyPr>
-          <a:lstStyle/>
-          <a:p>
-            <a:r>
-              <a:rPr lang="en-US" dirty="0"/>
-              <a:t>Tap 1</a:t>
-            </a:r>
-          </a:p>
-        </p:txBody>
-      </p:sp>
-      <p:sp>
-        <p:nvSpPr>
-          <p:cNvPr id="9" name="TextBox 8">
-            <a:extLst>
-              <a:ext uri="{FF2B5EF4-FFF2-40B4-BE49-F238E27FC236}">
-                <a16:creationId xmlns:a16="http://schemas.microsoft.com/office/drawing/2014/main" id="{8E7648B9-08C1-D9F4-71CB-78ED1AC0A028}"/>
-              </a:ext>
-            </a:extLst>
-          </p:cNvPr>
-          <p:cNvSpPr txBox="1"/>
-          <p:nvPr/>
-        </p:nvSpPr>
-        <p:spPr>
-          <a:xfrm>
-            <a:off x="5321859" y="3057577"/>
-            <a:ext cx="681212" cy="369332"/>
-          </a:xfrm>
-          <a:prstGeom prst="rect">
-            <a:avLst/>
-          </a:prstGeom>
-          <a:solidFill>
-            <a:schemeClr val="bg1"/>
-          </a:solidFill>
-        </p:spPr>
-        <p:txBody>
-          <a:bodyPr wrap="none" rtlCol="0">
-            <a:spAutoFit/>
-          </a:bodyPr>
-          <a:lstStyle/>
-          <a:p>
-            <a:r>
-              <a:rPr lang="en-US" dirty="0"/>
-              <a:t>Tap 2</a:t>
-            </a:r>
-          </a:p>
-        </p:txBody>
-      </p:sp>
-      <p:sp>
-        <p:nvSpPr>
-          <p:cNvPr id="10" name="TextBox 9">
-            <a:extLst>
-              <a:ext uri="{FF2B5EF4-FFF2-40B4-BE49-F238E27FC236}">
-                <a16:creationId xmlns:a16="http://schemas.microsoft.com/office/drawing/2014/main" id="{B903AAD3-528E-03C5-CFE3-DEC603C4D885}"/>
-              </a:ext>
-            </a:extLst>
-          </p:cNvPr>
-          <p:cNvSpPr txBox="1"/>
-          <p:nvPr/>
-        </p:nvSpPr>
-        <p:spPr>
-          <a:xfrm>
-            <a:off x="5321859" y="3822120"/>
-            <a:ext cx="681212" cy="369332"/>
-          </a:xfrm>
-          <a:prstGeom prst="rect">
-            <a:avLst/>
-          </a:prstGeom>
-          <a:solidFill>
-            <a:schemeClr val="bg1"/>
-          </a:solidFill>
-        </p:spPr>
-        <p:txBody>
-          <a:bodyPr wrap="none" rtlCol="0">
-            <a:spAutoFit/>
-          </a:bodyPr>
-          <a:lstStyle/>
-          <a:p>
-            <a:r>
-              <a:rPr lang="en-US" dirty="0"/>
-              <a:t>Tap 3</a:t>
-            </a:r>
-          </a:p>
-        </p:txBody>
-      </p:sp>
-      <p:pic>
-        <p:nvPicPr>
-          <p:cNvPr id="6" name="Picture 5">
-            <a:extLst>
-              <a:ext uri="{FF2B5EF4-FFF2-40B4-BE49-F238E27FC236}">
-                <a16:creationId xmlns:a16="http://schemas.microsoft.com/office/drawing/2014/main" id="{ED98CB2C-7BE6-BD1D-D84F-A9A12919F566}"/>
-              </a:ext>
-            </a:extLst>
-          </p:cNvPr>
-          <p:cNvPicPr>
-            <a:picLocks noChangeAspect="1"/>
-          </p:cNvPicPr>
-          <p:nvPr/>
-        </p:nvPicPr>
-        <p:blipFill>
-          <a:blip r:embed="rId4"/>
-          <a:stretch>
-            <a:fillRect/>
-          </a:stretch>
-        </p:blipFill>
-        <p:spPr>
-          <a:xfrm>
-            <a:off x="1457673" y="1804045"/>
-            <a:ext cx="2791012" cy="2871911"/>
-          </a:xfrm>
-          <a:prstGeom prst="rect">
-            <a:avLst/>
-          </a:prstGeom>
-        </p:spPr>
-      </p:pic>
-      <p:sp>
-        <p:nvSpPr>
-          <p:cNvPr id="7" name="TextBox 6">
-            <a:extLst>
-              <a:ext uri="{FF2B5EF4-FFF2-40B4-BE49-F238E27FC236}">
-                <a16:creationId xmlns:a16="http://schemas.microsoft.com/office/drawing/2014/main" id="{5355BEE4-036D-FD0B-86AE-E41ED60CD03A}"/>
-              </a:ext>
-            </a:extLst>
-          </p:cNvPr>
-          <p:cNvSpPr txBox="1"/>
-          <p:nvPr/>
-        </p:nvSpPr>
-        <p:spPr>
-          <a:xfrm>
-            <a:off x="489491" y="5366019"/>
-            <a:ext cx="5442387" cy="369332"/>
-          </a:xfrm>
-          <a:prstGeom prst="rect">
-            <a:avLst/>
-          </a:prstGeom>
-          <a:noFill/>
-        </p:spPr>
-        <p:txBody>
-          <a:bodyPr wrap="none" rtlCol="0">
-            <a:spAutoFit/>
-          </a:bodyPr>
-          <a:lstStyle/>
-          <a:p>
-            <a:r>
-              <a:rPr lang="en-US" dirty="0"/>
-              <a:t>Live Demo: </a:t>
-            </a:r>
-            <a:r>
-              <a:rPr lang="en-US" dirty="0">
-                <a:hlinkClick r:id="rId5"/>
-              </a:rPr>
-              <a:t>https://amonbenson.github.io/topology-sim</a:t>
-            </a:r>
-            <a:endParaRPr lang="en-US" dirty="0"/>
-          </a:p>
-        </p:txBody>
-      </p:sp>
+        </p:grpSpPr>
+        <p:pic>
+          <p:nvPicPr>
+            <p:cNvPr id="18" name="Picture 17" descr="A diagram of electrical wiring&#10;&#10;AI-generated content may be incorrect.">
+              <a:extLst>
+                <a:ext uri="{FF2B5EF4-FFF2-40B4-BE49-F238E27FC236}">
+                  <a16:creationId xmlns:a16="http://schemas.microsoft.com/office/drawing/2014/main" id="{8C5B2813-7E4B-911E-E8F0-0DF6EFF832F2}"/>
+                </a:ext>
+              </a:extLst>
+            </p:cNvPr>
+            <p:cNvPicPr>
+              <a:picLocks noChangeAspect="1"/>
+            </p:cNvPicPr>
+            <p:nvPr/>
+          </p:nvPicPr>
+          <p:blipFill>
+            <a:blip r:embed="rId3"/>
+            <a:srcRect l="26416"/>
+            <a:stretch>
+              <a:fillRect/>
+            </a:stretch>
+          </p:blipFill>
+          <p:spPr>
+            <a:xfrm>
+              <a:off x="6260123" y="638989"/>
+              <a:ext cx="4096651" cy="5150236"/>
+            </a:xfrm>
+            <a:prstGeom prst="rect">
+              <a:avLst/>
+            </a:prstGeom>
+          </p:spPr>
+        </p:pic>
+        <p:sp>
+          <p:nvSpPr>
+            <p:cNvPr id="2" name="TextBox 1">
+              <a:extLst>
+                <a:ext uri="{FF2B5EF4-FFF2-40B4-BE49-F238E27FC236}">
+                  <a16:creationId xmlns:a16="http://schemas.microsoft.com/office/drawing/2014/main" id="{D1138688-ACD6-A9EC-4AA2-BA77A21142A2}"/>
+                </a:ext>
+              </a:extLst>
+            </p:cNvPr>
+            <p:cNvSpPr txBox="1"/>
+            <p:nvPr/>
+          </p:nvSpPr>
+          <p:spPr>
+            <a:xfrm>
+              <a:off x="9115864" y="638989"/>
+              <a:ext cx="1125415" cy="523220"/>
+            </a:xfrm>
+            <a:prstGeom prst="rect">
+              <a:avLst/>
+            </a:prstGeom>
+            <a:solidFill>
+              <a:schemeClr val="bg1"/>
+            </a:solidFill>
+          </p:spPr>
+          <p:txBody>
+            <a:bodyPr wrap="square" rtlCol="0">
+              <a:spAutoFit/>
+            </a:bodyPr>
+            <a:lstStyle/>
+            <a:p>
+              <a:r>
+                <a:rPr lang="en-US" sz="2800" dirty="0">
+                  <a:solidFill>
+                    <a:schemeClr val="bg2">
+                      <a:lumMod val="10000"/>
+                    </a:schemeClr>
+                  </a:solidFill>
+                </a:rPr>
+                <a:t>+</a:t>
+              </a:r>
+              <a:r>
+                <a:rPr lang="de-DE" sz="2800" dirty="0">
+                  <a:solidFill>
+                    <a:schemeClr val="bg2">
+                      <a:lumMod val="10000"/>
+                    </a:schemeClr>
+                  </a:solidFill>
+                </a:rPr>
+                <a:t>3.3</a:t>
+              </a:r>
+              <a:r>
+                <a:rPr lang="en-US" sz="2800" dirty="0">
+                  <a:solidFill>
+                    <a:schemeClr val="bg2">
+                      <a:lumMod val="10000"/>
+                    </a:schemeClr>
+                  </a:solidFill>
+                </a:rPr>
+                <a:t>V</a:t>
+              </a:r>
+            </a:p>
+          </p:txBody>
+        </p:sp>
+        <p:sp>
+          <p:nvSpPr>
+            <p:cNvPr id="3" name="TextBox 2">
+              <a:extLst>
+                <a:ext uri="{FF2B5EF4-FFF2-40B4-BE49-F238E27FC236}">
+                  <a16:creationId xmlns:a16="http://schemas.microsoft.com/office/drawing/2014/main" id="{4C3D5FC2-4116-1C94-C0CD-F53CBF1B45CA}"/>
+                </a:ext>
+              </a:extLst>
+            </p:cNvPr>
+            <p:cNvSpPr txBox="1"/>
+            <p:nvPr/>
+          </p:nvSpPr>
+          <p:spPr>
+            <a:xfrm>
+              <a:off x="9115864" y="5266005"/>
+              <a:ext cx="1125415" cy="523220"/>
+            </a:xfrm>
+            <a:prstGeom prst="rect">
+              <a:avLst/>
+            </a:prstGeom>
+            <a:solidFill>
+              <a:schemeClr val="bg1"/>
+            </a:solidFill>
+          </p:spPr>
+          <p:txBody>
+            <a:bodyPr wrap="square" rtlCol="0">
+              <a:spAutoFit/>
+            </a:bodyPr>
+            <a:lstStyle/>
+            <a:p>
+              <a:r>
+                <a:rPr lang="en-US" sz="2800" dirty="0">
+                  <a:solidFill>
+                    <a:schemeClr val="bg2">
+                      <a:lumMod val="10000"/>
+                    </a:schemeClr>
+                  </a:solidFill>
+                </a:rPr>
+                <a:t>GND</a:t>
+              </a:r>
+            </a:p>
+          </p:txBody>
+        </p:sp>
+        <p:pic>
+          <p:nvPicPr>
+            <p:cNvPr id="4" name="Picture 3" descr="A diagram of electrical wiring&#10;&#10;AI-generated content may be incorrect.">
+              <a:extLst>
+                <a:ext uri="{FF2B5EF4-FFF2-40B4-BE49-F238E27FC236}">
+                  <a16:creationId xmlns:a16="http://schemas.microsoft.com/office/drawing/2014/main" id="{E98700CC-887E-0697-C52C-2874EE6F1C50}"/>
+                </a:ext>
+              </a:extLst>
+            </p:cNvPr>
+            <p:cNvPicPr>
+              <a:picLocks noChangeAspect="1"/>
+            </p:cNvPicPr>
+            <p:nvPr/>
+          </p:nvPicPr>
+          <p:blipFill>
+            <a:blip r:embed="rId3"/>
+            <a:srcRect r="87259"/>
+            <a:stretch>
+              <a:fillRect/>
+            </a:stretch>
+          </p:blipFill>
+          <p:spPr>
+            <a:xfrm>
+              <a:off x="5689747" y="638989"/>
+              <a:ext cx="709348" cy="5150236"/>
+            </a:xfrm>
+            <a:prstGeom prst="rect">
+              <a:avLst/>
+            </a:prstGeom>
+          </p:spPr>
+        </p:pic>
+        <p:sp>
+          <p:nvSpPr>
+            <p:cNvPr id="8" name="TextBox 7">
+              <a:extLst>
+                <a:ext uri="{FF2B5EF4-FFF2-40B4-BE49-F238E27FC236}">
+                  <a16:creationId xmlns:a16="http://schemas.microsoft.com/office/drawing/2014/main" id="{C4F020C3-EBC6-2172-DB34-B04E9D82184A}"/>
+                </a:ext>
+              </a:extLst>
+            </p:cNvPr>
+            <p:cNvSpPr txBox="1"/>
+            <p:nvPr/>
+          </p:nvSpPr>
+          <p:spPr>
+            <a:xfrm>
+              <a:off x="5321859" y="2293034"/>
+              <a:ext cx="681212" cy="369332"/>
+            </a:xfrm>
+            <a:prstGeom prst="rect">
+              <a:avLst/>
+            </a:prstGeom>
+            <a:solidFill>
+              <a:schemeClr val="bg1"/>
+            </a:solidFill>
+          </p:spPr>
+          <p:txBody>
+            <a:bodyPr wrap="none" rtlCol="0">
+              <a:spAutoFit/>
+            </a:bodyPr>
+            <a:lstStyle/>
+            <a:p>
+              <a:r>
+                <a:rPr lang="en-US" dirty="0"/>
+                <a:t>Tap 1</a:t>
+              </a:r>
+            </a:p>
+          </p:txBody>
+        </p:sp>
+        <p:sp>
+          <p:nvSpPr>
+            <p:cNvPr id="9" name="TextBox 8">
+              <a:extLst>
+                <a:ext uri="{FF2B5EF4-FFF2-40B4-BE49-F238E27FC236}">
+                  <a16:creationId xmlns:a16="http://schemas.microsoft.com/office/drawing/2014/main" id="{8E7648B9-08C1-D9F4-71CB-78ED1AC0A028}"/>
+                </a:ext>
+              </a:extLst>
+            </p:cNvPr>
+            <p:cNvSpPr txBox="1"/>
+            <p:nvPr/>
+          </p:nvSpPr>
+          <p:spPr>
+            <a:xfrm>
+              <a:off x="5321859" y="3057577"/>
+              <a:ext cx="681212" cy="369332"/>
+            </a:xfrm>
+            <a:prstGeom prst="rect">
+              <a:avLst/>
+            </a:prstGeom>
+            <a:solidFill>
+              <a:schemeClr val="bg1"/>
+            </a:solidFill>
+          </p:spPr>
+          <p:txBody>
+            <a:bodyPr wrap="none" rtlCol="0">
+              <a:spAutoFit/>
+            </a:bodyPr>
+            <a:lstStyle/>
+            <a:p>
+              <a:r>
+                <a:rPr lang="en-US" dirty="0"/>
+                <a:t>Tap 2</a:t>
+              </a:r>
+            </a:p>
+          </p:txBody>
+        </p:sp>
+        <p:sp>
+          <p:nvSpPr>
+            <p:cNvPr id="10" name="TextBox 9">
+              <a:extLst>
+                <a:ext uri="{FF2B5EF4-FFF2-40B4-BE49-F238E27FC236}">
+                  <a16:creationId xmlns:a16="http://schemas.microsoft.com/office/drawing/2014/main" id="{B903AAD3-528E-03C5-CFE3-DEC603C4D885}"/>
+                </a:ext>
+              </a:extLst>
+            </p:cNvPr>
+            <p:cNvSpPr txBox="1"/>
+            <p:nvPr/>
+          </p:nvSpPr>
+          <p:spPr>
+            <a:xfrm>
+              <a:off x="5321859" y="3822120"/>
+              <a:ext cx="681212" cy="369332"/>
+            </a:xfrm>
+            <a:prstGeom prst="rect">
+              <a:avLst/>
+            </a:prstGeom>
+            <a:solidFill>
+              <a:schemeClr val="bg1"/>
+            </a:solidFill>
+          </p:spPr>
+          <p:txBody>
+            <a:bodyPr wrap="none" rtlCol="0">
+              <a:spAutoFit/>
+            </a:bodyPr>
+            <a:lstStyle/>
+            <a:p>
+              <a:r>
+                <a:rPr lang="en-US" dirty="0"/>
+                <a:t>Tap 3</a:t>
+              </a:r>
+            </a:p>
+          </p:txBody>
+        </p:sp>
+      </p:grpSp>
     </p:spTree>
     <p:extLst>
       <p:ext uri="{BB962C8B-B14F-4D97-AF65-F5344CB8AC3E}">
@@ -8843,7 +8640,7 @@
         <p:cNvPr id="1" name="">
           <a:extLst>
             <a:ext uri="{FF2B5EF4-FFF2-40B4-BE49-F238E27FC236}">
-              <a16:creationId xmlns:a16="http://schemas.microsoft.com/office/drawing/2014/main" id="{BF93C7B9-373F-DEDC-5C13-3D95C3E20B24}"/>
+              <a16:creationId xmlns:a16="http://schemas.microsoft.com/office/drawing/2014/main" id="{05C45916-DA8E-3578-97F1-0FC2045F5ACD}"/>
             </a:ext>
           </a:extLst>
         </p:cNvPr>
@@ -8860,98 +8657,10 @@
       </p:grpSpPr>
       <p:sp>
         <p:nvSpPr>
-          <p:cNvPr id="6" name="Text Placeholder 5">
-            <a:extLst>
-              <a:ext uri="{FF2B5EF4-FFF2-40B4-BE49-F238E27FC236}">
-                <a16:creationId xmlns:a16="http://schemas.microsoft.com/office/drawing/2014/main" id="{51EDEFEC-2C57-53B6-B2D8-27ADF4842729}"/>
-              </a:ext>
-            </a:extLst>
-          </p:cNvPr>
-          <p:cNvSpPr>
-            <a:spLocks noGrp="1"/>
-          </p:cNvSpPr>
-          <p:nvPr>
-            <p:ph type="body" sz="quarter" idx="18"/>
-          </p:nvPr>
-        </p:nvSpPr>
-        <p:spPr>
-          <a:xfrm>
-            <a:off x="550800" y="1519311"/>
-            <a:ext cx="11055046" cy="4051495"/>
-          </a:xfrm>
-        </p:spPr>
-        <p:txBody>
-          <a:bodyPr/>
-          <a:lstStyle/>
-          <a:p>
-            <a:r>
-              <a:rPr lang="en-US" dirty="0"/>
-              <a:t>Hardware</a:t>
-            </a:r>
-          </a:p>
-          <a:p>
-            <a:pPr lvl="1"/>
-            <a:r>
-              <a:rPr lang="en-US" strike="sngStrike" dirty="0"/>
-              <a:t>schematic design</a:t>
-            </a:r>
-          </a:p>
-          <a:p>
-            <a:pPr lvl="1"/>
-            <a:r>
-              <a:rPr lang="en-US" dirty="0"/>
-              <a:t>build a working prototype (single channel)</a:t>
-            </a:r>
-          </a:p>
-          <a:p>
-            <a:pPr lvl="1"/>
-            <a:r>
-              <a:rPr lang="en-US" dirty="0"/>
-              <a:t>PCB layout and routing</a:t>
-            </a:r>
-          </a:p>
-          <a:p>
-            <a:pPr lvl="1"/>
-            <a:r>
-              <a:rPr lang="en-US" dirty="0"/>
-              <a:t>manufacturing</a:t>
-            </a:r>
-          </a:p>
-          <a:p>
-            <a:r>
-              <a:rPr lang="en-US" dirty="0"/>
-              <a:t>Firmware</a:t>
-            </a:r>
-          </a:p>
-          <a:p>
-            <a:pPr lvl="1"/>
-            <a:r>
-              <a:rPr lang="en-US" strike="sngStrike" dirty="0"/>
-              <a:t>simulation of ADC measurements for (functional) testing</a:t>
-            </a:r>
-          </a:p>
-          <a:p>
-            <a:pPr lvl="1"/>
-            <a:r>
-              <a:rPr lang="en-US" strike="sngStrike" dirty="0"/>
-              <a:t>implementation and refinement of the detection algorithm</a:t>
-            </a:r>
-          </a:p>
-          <a:p>
-            <a:pPr lvl="1"/>
-            <a:r>
-              <a:rPr lang="en-US" dirty="0"/>
-              <a:t>implementation of the detection algorithm using the microcontroller toolchain</a:t>
-            </a:r>
-          </a:p>
-        </p:txBody>
-      </p:sp>
-      <p:sp>
-        <p:nvSpPr>
           <p:cNvPr id="5" name="Text Placeholder 4">
             <a:extLst>
               <a:ext uri="{FF2B5EF4-FFF2-40B4-BE49-F238E27FC236}">
-                <a16:creationId xmlns:a16="http://schemas.microsoft.com/office/drawing/2014/main" id="{8594DE85-E3F6-F30B-A8E2-B0BF48E8E1CB}"/>
+                <a16:creationId xmlns:a16="http://schemas.microsoft.com/office/drawing/2014/main" id="{EA6F5308-317E-5C32-F6BD-107ED760C7DD}"/>
               </a:ext>
             </a:extLst>
           </p:cNvPr>
@@ -8964,8 +8673,8 @@
         </p:nvSpPr>
         <p:spPr>
           <a:xfrm>
-            <a:off x="555867" y="396545"/>
-            <a:ext cx="8311908" cy="717437"/>
+            <a:off x="555867" y="37826"/>
+            <a:ext cx="8311908" cy="517345"/>
           </a:xfrm>
         </p:spPr>
         <p:txBody>
@@ -8974,15 +8683,45 @@
           <a:p>
             <a:r>
               <a:rPr lang="en-US" dirty="0"/>
-              <a:t>Outlook</a:t>
+              <a:t>Differences to Milestone 1 Schematics</a:t>
             </a:r>
           </a:p>
         </p:txBody>
       </p:sp>
+      <p:pic>
+        <p:nvPicPr>
+          <p:cNvPr id="13" name="Picture 12">
+            <a:extLst>
+              <a:ext uri="{FF2B5EF4-FFF2-40B4-BE49-F238E27FC236}">
+                <a16:creationId xmlns:a16="http://schemas.microsoft.com/office/drawing/2014/main" id="{5AC1DF7E-F916-8F35-7E6E-AE3A5DB5863D}"/>
+              </a:ext>
+            </a:extLst>
+          </p:cNvPr>
+          <p:cNvPicPr>
+            <a:picLocks noChangeAspect="1"/>
+          </p:cNvPicPr>
+          <p:nvPr/>
+        </p:nvPicPr>
+        <p:blipFill>
+          <a:blip r:embed="rId3"/>
+          <a:stretch>
+            <a:fillRect/>
+          </a:stretch>
+        </p:blipFill>
+        <p:spPr>
+          <a:xfrm>
+            <a:off x="1697491" y="555170"/>
+            <a:ext cx="8797018" cy="5709559"/>
+          </a:xfrm>
+          <a:prstGeom prst="rect">
+            <a:avLst/>
+          </a:prstGeom>
+        </p:spPr>
+      </p:pic>
     </p:spTree>
     <p:extLst>
       <p:ext uri="{BB962C8B-B14F-4D97-AF65-F5344CB8AC3E}">
-        <p14:creationId xmlns:p14="http://schemas.microsoft.com/office/powerpoint/2010/main" val="1957977642"/>
+        <p14:creationId xmlns:p14="http://schemas.microsoft.com/office/powerpoint/2010/main" val="2862622974"/>
       </p:ext>
     </p:extLst>
   </p:cSld>

</xml_diff>